<commit_message>
adding tables list completed
</commit_message>
<xml_diff>
--- a/datamesh-webapp/design.pptx
+++ b/datamesh-webapp/design.pptx
@@ -3770,7 +3770,7 @@
                     <a:bodyPr/>
                     <a:lstStyle/>
                     <a:p>
-                      <a:endParaRPr lang="en-US"/>
+                      <a:endParaRPr lang="en-US" dirty="0"/>
                     </a:p>
                   </a:txBody>
                   <a:tcPr/>
@@ -3977,10 +3977,10 @@
       </p:grpSpPr>
       <p:graphicFrame>
         <p:nvGraphicFramePr>
-          <p:cNvPr id="4" name="Table 3">
-            <a:extLst>
-              <a:ext uri="{FF2B5EF4-FFF2-40B4-BE49-F238E27FC236}">
-                <a16:creationId xmlns:a16="http://schemas.microsoft.com/office/drawing/2014/main" id="{C0B6D719-1F9E-5516-29DD-339C402B1C5D}"/>
+          <p:cNvPr id="10" name="Table 9">
+            <a:extLst>
+              <a:ext uri="{FF2B5EF4-FFF2-40B4-BE49-F238E27FC236}">
+                <a16:creationId xmlns:a16="http://schemas.microsoft.com/office/drawing/2014/main" id="{8962393C-C73A-22C6-CBE4-9110C0ADA2A6}"/>
               </a:ext>
             </a:extLst>
           </p:cNvPr>
@@ -3990,14 +3990,14 @@
           <p:nvPr>
             <p:extLst>
               <p:ext uri="{D42A27DB-BD31-4B8C-83A1-F6EECF244321}">
-                <p14:modId xmlns:p14="http://schemas.microsoft.com/office/powerpoint/2010/main" val="1133767373"/>
+                <p14:modId xmlns:p14="http://schemas.microsoft.com/office/powerpoint/2010/main" val="4035994195"/>
               </p:ext>
             </p:extLst>
           </p:nvPr>
         </p:nvGraphicFramePr>
         <p:xfrm>
-          <a:off x="1574800" y="376084"/>
-          <a:ext cx="8128001" cy="2468880"/>
+          <a:off x="2032000" y="719666"/>
+          <a:ext cx="8128001" cy="1005840"/>
         </p:xfrm>
         <a:graphic>
           <a:graphicData uri="http://schemas.openxmlformats.org/drawingml/2006/table">
@@ -4056,7 +4056,7 @@
                   </a:extLst>
                 </a:gridCol>
               </a:tblGrid>
-              <a:tr h="250759">
+              <a:tr h="269486">
                 <a:tc>
                   <a:txBody>
                     <a:bodyPr/>
@@ -4155,23 +4155,16 @@
                   </a:ext>
                 </a:extLst>
               </a:tr>
-              <a:tr h="145281">
-                <a:tc>
-                  <a:txBody>
-                    <a:bodyPr/>
-                    <a:lstStyle/>
-                    <a:p>
-                      <a:endParaRPr lang="en-US" dirty="0"/>
-                    </a:p>
-                  </a:txBody>
-                  <a:tcPr/>
-                </a:tc>
-                <a:tc>
-                  <a:txBody>
-                    <a:bodyPr/>
-                    <a:lstStyle/>
-                    <a:p>
-                      <a:endParaRPr lang="en-US" dirty="0"/>
+              <a:tr h="156131">
+                <a:tc>
+                  <a:txBody>
+                    <a:bodyPr/>
+                    <a:lstStyle/>
+                    <a:p>
+                      <a:r>
+                        <a:rPr lang="en-US" dirty="0"/>
+                        <a:t>00023</a:t>
+                      </a:r>
                     </a:p>
                   </a:txBody>
                   <a:tcPr/>
@@ -4194,37 +4187,66 @@
                     <a:bodyPr/>
                     <a:lstStyle/>
                     <a:p>
-                      <a:endParaRPr lang="en-US"/>
-                    </a:p>
-                  </a:txBody>
-                  <a:tcPr/>
-                </a:tc>
-                <a:tc>
-                  <a:txBody>
-                    <a:bodyPr/>
-                    <a:lstStyle/>
-                    <a:p>
-                      <a:endParaRPr lang="en-US"/>
-                    </a:p>
-                  </a:txBody>
-                  <a:tcPr/>
-                </a:tc>
-                <a:tc>
-                  <a:txBody>
-                    <a:bodyPr/>
-                    <a:lstStyle/>
-                    <a:p>
-                      <a:endParaRPr lang="en-US"/>
-                    </a:p>
-                  </a:txBody>
-                  <a:tcPr/>
-                </a:tc>
-                <a:tc>
-                  <a:txBody>
-                    <a:bodyPr/>
-                    <a:lstStyle/>
-                    <a:p>
-                      <a:endParaRPr lang="en-US"/>
+                      <a:r>
+                        <a:rPr lang="en-US" dirty="0">
+                          <a:highlight>
+                            <a:srgbClr val="FFFF00"/>
+                          </a:highlight>
+                        </a:rPr>
+                        <a:t>WEST</a:t>
+                      </a:r>
+                    </a:p>
+                  </a:txBody>
+                  <a:tcPr/>
+                </a:tc>
+                <a:tc>
+                  <a:txBody>
+                    <a:bodyPr/>
+                    <a:lstStyle/>
+                    <a:p>
+                      <a:r>
+                        <a:rPr lang="en-US" dirty="0"/>
+                        <a:t>Manager</a:t>
+                      </a:r>
+                    </a:p>
+                  </a:txBody>
+                  <a:tcPr/>
+                </a:tc>
+                <a:tc>
+                  <a:txBody>
+                    <a:bodyPr/>
+                    <a:lstStyle/>
+                    <a:p>
+                      <a:r>
+                        <a:rPr lang="en-US" dirty="0"/>
+                        <a:t>80</a:t>
+                      </a:r>
+                    </a:p>
+                  </a:txBody>
+                  <a:tcPr/>
+                </a:tc>
+                <a:tc>
+                  <a:txBody>
+                    <a:bodyPr/>
+                    <a:lstStyle/>
+                    <a:p>
+                      <a:r>
+                        <a:rPr lang="en-US" dirty="0"/>
+                        <a:t>1</a:t>
+                      </a:r>
+                    </a:p>
+                  </a:txBody>
+                  <a:tcPr/>
+                </a:tc>
+                <a:tc>
+                  <a:txBody>
+                    <a:bodyPr/>
+                    <a:lstStyle/>
+                    <a:p>
+                      <a:r>
+                        <a:rPr lang="en-US" dirty="0"/>
+                        <a:t>80</a:t>
+                      </a:r>
                     </a:p>
                   </a:txBody>
                   <a:tcPr/>
@@ -4232,314 +4254,6 @@
                 <a:extLst>
                   <a:ext uri="{0D108BD9-81ED-4DB2-BD59-A6C34878D82A}">
                     <a16:rowId xmlns:a16="http://schemas.microsoft.com/office/drawing/2014/main" val="2624418906"/>
-                  </a:ext>
-                </a:extLst>
-              </a:tr>
-              <a:tr h="145281">
-                <a:tc>
-                  <a:txBody>
-                    <a:bodyPr/>
-                    <a:lstStyle/>
-                    <a:p>
-                      <a:endParaRPr lang="en-US" dirty="0"/>
-                    </a:p>
-                  </a:txBody>
-                  <a:tcPr/>
-                </a:tc>
-                <a:tc>
-                  <a:txBody>
-                    <a:bodyPr/>
-                    <a:lstStyle/>
-                    <a:p>
-                      <a:endParaRPr lang="en-US"/>
-                    </a:p>
-                  </a:txBody>
-                  <a:tcPr/>
-                </a:tc>
-                <a:tc>
-                  <a:txBody>
-                    <a:bodyPr/>
-                    <a:lstStyle/>
-                    <a:p>
-                      <a:endParaRPr lang="en-US"/>
-                    </a:p>
-                  </a:txBody>
-                  <a:tcPr/>
-                </a:tc>
-                <a:tc>
-                  <a:txBody>
-                    <a:bodyPr/>
-                    <a:lstStyle/>
-                    <a:p>
-                      <a:endParaRPr lang="en-US"/>
-                    </a:p>
-                  </a:txBody>
-                  <a:tcPr/>
-                </a:tc>
-                <a:tc>
-                  <a:txBody>
-                    <a:bodyPr/>
-                    <a:lstStyle/>
-                    <a:p>
-                      <a:endParaRPr lang="en-US"/>
-                    </a:p>
-                  </a:txBody>
-                  <a:tcPr/>
-                </a:tc>
-                <a:tc>
-                  <a:txBody>
-                    <a:bodyPr/>
-                    <a:lstStyle/>
-                    <a:p>
-                      <a:endParaRPr lang="en-US"/>
-                    </a:p>
-                  </a:txBody>
-                  <a:tcPr/>
-                </a:tc>
-                <a:tc>
-                  <a:txBody>
-                    <a:bodyPr/>
-                    <a:lstStyle/>
-                    <a:p>
-                      <a:endParaRPr lang="en-US"/>
-                    </a:p>
-                  </a:txBody>
-                  <a:tcPr/>
-                </a:tc>
-                <a:extLst>
-                  <a:ext uri="{0D108BD9-81ED-4DB2-BD59-A6C34878D82A}">
-                    <a16:rowId xmlns:a16="http://schemas.microsoft.com/office/drawing/2014/main" val="3708326895"/>
-                  </a:ext>
-                </a:extLst>
-              </a:tr>
-              <a:tr h="145281">
-                <a:tc>
-                  <a:txBody>
-                    <a:bodyPr/>
-                    <a:lstStyle/>
-                    <a:p>
-                      <a:endParaRPr lang="en-US"/>
-                    </a:p>
-                  </a:txBody>
-                  <a:tcPr/>
-                </a:tc>
-                <a:tc>
-                  <a:txBody>
-                    <a:bodyPr/>
-                    <a:lstStyle/>
-                    <a:p>
-                      <a:endParaRPr lang="en-US"/>
-                    </a:p>
-                  </a:txBody>
-                  <a:tcPr/>
-                </a:tc>
-                <a:tc>
-                  <a:txBody>
-                    <a:bodyPr/>
-                    <a:lstStyle/>
-                    <a:p>
-                      <a:endParaRPr lang="en-US"/>
-                    </a:p>
-                  </a:txBody>
-                  <a:tcPr/>
-                </a:tc>
-                <a:tc>
-                  <a:txBody>
-                    <a:bodyPr/>
-                    <a:lstStyle/>
-                    <a:p>
-                      <a:endParaRPr lang="en-US"/>
-                    </a:p>
-                  </a:txBody>
-                  <a:tcPr/>
-                </a:tc>
-                <a:tc>
-                  <a:txBody>
-                    <a:bodyPr/>
-                    <a:lstStyle/>
-                    <a:p>
-                      <a:endParaRPr lang="en-US"/>
-                    </a:p>
-                  </a:txBody>
-                  <a:tcPr/>
-                </a:tc>
-                <a:tc>
-                  <a:txBody>
-                    <a:bodyPr/>
-                    <a:lstStyle/>
-                    <a:p>
-                      <a:endParaRPr lang="en-US"/>
-                    </a:p>
-                  </a:txBody>
-                  <a:tcPr/>
-                </a:tc>
-                <a:tc>
-                  <a:txBody>
-                    <a:bodyPr/>
-                    <a:lstStyle/>
-                    <a:p>
-                      <a:endParaRPr lang="en-US"/>
-                    </a:p>
-                  </a:txBody>
-                  <a:tcPr/>
-                </a:tc>
-                <a:extLst>
-                  <a:ext uri="{0D108BD9-81ED-4DB2-BD59-A6C34878D82A}">
-                    <a16:rowId xmlns:a16="http://schemas.microsoft.com/office/drawing/2014/main" val="2758168549"/>
-                  </a:ext>
-                </a:extLst>
-              </a:tr>
-              <a:tr h="145281">
-                <a:tc>
-                  <a:txBody>
-                    <a:bodyPr/>
-                    <a:lstStyle/>
-                    <a:p>
-                      <a:endParaRPr lang="en-US"/>
-                    </a:p>
-                  </a:txBody>
-                  <a:tcPr/>
-                </a:tc>
-                <a:tc>
-                  <a:txBody>
-                    <a:bodyPr/>
-                    <a:lstStyle/>
-                    <a:p>
-                      <a:endParaRPr lang="en-US"/>
-                    </a:p>
-                  </a:txBody>
-                  <a:tcPr/>
-                </a:tc>
-                <a:tc>
-                  <a:txBody>
-                    <a:bodyPr/>
-                    <a:lstStyle/>
-                    <a:p>
-                      <a:endParaRPr lang="en-US"/>
-                    </a:p>
-                  </a:txBody>
-                  <a:tcPr/>
-                </a:tc>
-                <a:tc>
-                  <a:txBody>
-                    <a:bodyPr/>
-                    <a:lstStyle/>
-                    <a:p>
-                      <a:endParaRPr lang="en-US"/>
-                    </a:p>
-                  </a:txBody>
-                  <a:tcPr/>
-                </a:tc>
-                <a:tc>
-                  <a:txBody>
-                    <a:bodyPr/>
-                    <a:lstStyle/>
-                    <a:p>
-                      <a:endParaRPr lang="en-US"/>
-                    </a:p>
-                  </a:txBody>
-                  <a:tcPr/>
-                </a:tc>
-                <a:tc>
-                  <a:txBody>
-                    <a:bodyPr/>
-                    <a:lstStyle/>
-                    <a:p>
-                      <a:endParaRPr lang="en-US"/>
-                    </a:p>
-                  </a:txBody>
-                  <a:tcPr/>
-                </a:tc>
-                <a:tc>
-                  <a:txBody>
-                    <a:bodyPr/>
-                    <a:lstStyle/>
-                    <a:p>
-                      <a:endParaRPr lang="en-US"/>
-                    </a:p>
-                  </a:txBody>
-                  <a:tcPr/>
-                </a:tc>
-                <a:extLst>
-                  <a:ext uri="{0D108BD9-81ED-4DB2-BD59-A6C34878D82A}">
-                    <a16:rowId xmlns:a16="http://schemas.microsoft.com/office/drawing/2014/main" val="4087349432"/>
-                  </a:ext>
-                </a:extLst>
-              </a:tr>
-              <a:tr h="145281">
-                <a:tc>
-                  <a:txBody>
-                    <a:bodyPr/>
-                    <a:lstStyle/>
-                    <a:p>
-                      <a:endParaRPr lang="en-US"/>
-                    </a:p>
-                  </a:txBody>
-                  <a:tcPr/>
-                </a:tc>
-                <a:tc>
-                  <a:txBody>
-                    <a:bodyPr/>
-                    <a:lstStyle/>
-                    <a:p>
-                      <a:endParaRPr lang="en-US"/>
-                    </a:p>
-                  </a:txBody>
-                  <a:tcPr/>
-                </a:tc>
-                <a:tc>
-                  <a:txBody>
-                    <a:bodyPr/>
-                    <a:lstStyle/>
-                    <a:p>
-                      <a:endParaRPr lang="en-US"/>
-                    </a:p>
-                  </a:txBody>
-                  <a:tcPr/>
-                </a:tc>
-                <a:tc>
-                  <a:txBody>
-                    <a:bodyPr/>
-                    <a:lstStyle/>
-                    <a:p>
-                      <a:endParaRPr lang="en-US"/>
-                    </a:p>
-                  </a:txBody>
-                  <a:tcPr/>
-                </a:tc>
-                <a:tc>
-                  <a:txBody>
-                    <a:bodyPr/>
-                    <a:lstStyle/>
-                    <a:p>
-                      <a:endParaRPr lang="en-US"/>
-                    </a:p>
-                  </a:txBody>
-                  <a:tcPr/>
-                </a:tc>
-                <a:tc>
-                  <a:txBody>
-                    <a:bodyPr/>
-                    <a:lstStyle/>
-                    <a:p>
-                      <a:endParaRPr lang="en-US"/>
-                    </a:p>
-                  </a:txBody>
-                  <a:tcPr/>
-                </a:tc>
-                <a:tc>
-                  <a:txBody>
-                    <a:bodyPr/>
-                    <a:lstStyle/>
-                    <a:p>
-                      <a:endParaRPr lang="en-US" dirty="0"/>
-                    </a:p>
-                  </a:txBody>
-                  <a:tcPr/>
-                </a:tc>
-                <a:extLst>
-                  <a:ext uri="{0D108BD9-81ED-4DB2-BD59-A6C34878D82A}">
-                    <a16:rowId xmlns:a16="http://schemas.microsoft.com/office/drawing/2014/main" val="1311239789"/>
                   </a:ext>
                 </a:extLst>
               </a:tr>
@@ -4549,10 +4263,10 @@
       </p:graphicFrame>
       <p:graphicFrame>
         <p:nvGraphicFramePr>
-          <p:cNvPr id="5" name="Table 4">
-            <a:extLst>
-              <a:ext uri="{FF2B5EF4-FFF2-40B4-BE49-F238E27FC236}">
-                <a16:creationId xmlns:a16="http://schemas.microsoft.com/office/drawing/2014/main" id="{409DE409-89F9-93AA-CD85-F64C779D12A2}"/>
+          <p:cNvPr id="11" name="Table 10">
+            <a:extLst>
+              <a:ext uri="{FF2B5EF4-FFF2-40B4-BE49-F238E27FC236}">
+                <a16:creationId xmlns:a16="http://schemas.microsoft.com/office/drawing/2014/main" id="{F237B847-5068-162F-A382-3843A040ABD0}"/>
               </a:ext>
             </a:extLst>
           </p:cNvPr>
@@ -4562,14 +4276,14 @@
           <p:nvPr>
             <p:extLst>
               <p:ext uri="{D42A27DB-BD31-4B8C-83A1-F6EECF244321}">
-                <p14:modId xmlns:p14="http://schemas.microsoft.com/office/powerpoint/2010/main" val="942241068"/>
+                <p14:modId xmlns:p14="http://schemas.microsoft.com/office/powerpoint/2010/main" val="3670192560"/>
               </p:ext>
             </p:extLst>
           </p:nvPr>
         </p:nvGraphicFramePr>
         <p:xfrm>
-          <a:off x="2031999" y="1279505"/>
-          <a:ext cx="8128001" cy="2763520"/>
+          <a:off x="2032000" y="2181860"/>
+          <a:ext cx="8128001" cy="2494280"/>
         </p:xfrm>
         <a:graphic>
           <a:graphicData uri="http://schemas.openxmlformats.org/drawingml/2006/table">
@@ -4581,49 +4295,49 @@
                 <a:gridCol w="1161143">
                   <a:extLst>
                     <a:ext uri="{9D8B030D-6E8A-4147-A177-3AD203B41FA5}">
-                      <a16:colId xmlns:a16="http://schemas.microsoft.com/office/drawing/2014/main" val="2366057514"/>
-                    </a:ext>
-                  </a:extLst>
-                </a:gridCol>
-                <a:gridCol w="1496845">
-                  <a:extLst>
-                    <a:ext uri="{9D8B030D-6E8A-4147-A177-3AD203B41FA5}">
-                      <a16:colId xmlns:a16="http://schemas.microsoft.com/office/drawing/2014/main" val="918646822"/>
-                    </a:ext>
-                  </a:extLst>
-                </a:gridCol>
-                <a:gridCol w="1120878">
-                  <a:extLst>
-                    <a:ext uri="{9D8B030D-6E8A-4147-A177-3AD203B41FA5}">
-                      <a16:colId xmlns:a16="http://schemas.microsoft.com/office/drawing/2014/main" val="806062097"/>
-                    </a:ext>
-                  </a:extLst>
-                </a:gridCol>
-                <a:gridCol w="865706">
-                  <a:extLst>
-                    <a:ext uri="{9D8B030D-6E8A-4147-A177-3AD203B41FA5}">
-                      <a16:colId xmlns:a16="http://schemas.microsoft.com/office/drawing/2014/main" val="1250058706"/>
+                      <a16:colId xmlns:a16="http://schemas.microsoft.com/office/drawing/2014/main" val="3042990087"/>
                     </a:ext>
                   </a:extLst>
                 </a:gridCol>
                 <a:gridCol w="1161143">
                   <a:extLst>
                     <a:ext uri="{9D8B030D-6E8A-4147-A177-3AD203B41FA5}">
-                      <a16:colId xmlns:a16="http://schemas.microsoft.com/office/drawing/2014/main" val="1684550294"/>
+                      <a16:colId xmlns:a16="http://schemas.microsoft.com/office/drawing/2014/main" val="1189862509"/>
                     </a:ext>
                   </a:extLst>
                 </a:gridCol>
                 <a:gridCol w="1161143">
                   <a:extLst>
                     <a:ext uri="{9D8B030D-6E8A-4147-A177-3AD203B41FA5}">
-                      <a16:colId xmlns:a16="http://schemas.microsoft.com/office/drawing/2014/main" val="30954544"/>
+                      <a16:colId xmlns:a16="http://schemas.microsoft.com/office/drawing/2014/main" val="2195666933"/>
                     </a:ext>
                   </a:extLst>
                 </a:gridCol>
                 <a:gridCol w="1161143">
                   <a:extLst>
                     <a:ext uri="{9D8B030D-6E8A-4147-A177-3AD203B41FA5}">
-                      <a16:colId xmlns:a16="http://schemas.microsoft.com/office/drawing/2014/main" val="2557522844"/>
+                      <a16:colId xmlns:a16="http://schemas.microsoft.com/office/drawing/2014/main" val="3551388330"/>
+                    </a:ext>
+                  </a:extLst>
+                </a:gridCol>
+                <a:gridCol w="1161143">
+                  <a:extLst>
+                    <a:ext uri="{9D8B030D-6E8A-4147-A177-3AD203B41FA5}">
+                      <a16:colId xmlns:a16="http://schemas.microsoft.com/office/drawing/2014/main" val="859217830"/>
+                    </a:ext>
+                  </a:extLst>
+                </a:gridCol>
+                <a:gridCol w="1161143">
+                  <a:extLst>
+                    <a:ext uri="{9D8B030D-6E8A-4147-A177-3AD203B41FA5}">
+                      <a16:colId xmlns:a16="http://schemas.microsoft.com/office/drawing/2014/main" val="1214345371"/>
+                    </a:ext>
+                  </a:extLst>
+                </a:gridCol>
+                <a:gridCol w="1161143">
+                  <a:extLst>
+                    <a:ext uri="{9D8B030D-6E8A-4147-A177-3AD203B41FA5}">
+                      <a16:colId xmlns:a16="http://schemas.microsoft.com/office/drawing/2014/main" val="335725468"/>
                     </a:ext>
                   </a:extLst>
                 </a:gridCol>
@@ -4634,6 +4348,49 @@
                     <a:bodyPr/>
                     <a:lstStyle/>
                     <a:p>
+                      <a:r>
+                        <a:rPr lang="en-US" dirty="0"/>
+                        <a:t>Club</a:t>
+                      </a:r>
+                    </a:p>
+                  </a:txBody>
+                  <a:tcPr/>
+                </a:tc>
+                <a:tc>
+                  <a:txBody>
+                    <a:bodyPr/>
+                    <a:lstStyle/>
+                    <a:p>
+                      <a:r>
+                        <a:rPr lang="en-US" dirty="0"/>
+                        <a:t>Region</a:t>
+                      </a:r>
+                    </a:p>
+                  </a:txBody>
+                  <a:tcPr/>
+                </a:tc>
+                <a:tc>
+                  <a:txBody>
+                    <a:bodyPr/>
+                    <a:lstStyle/>
+                    <a:p>
+                      <a:r>
+                        <a:rPr lang="en-US" dirty="0"/>
+                        <a:t>District</a:t>
+                      </a:r>
+                    </a:p>
+                  </a:txBody>
+                  <a:tcPr/>
+                </a:tc>
+                <a:tc>
+                  <a:txBody>
+                    <a:bodyPr/>
+                    <a:lstStyle/>
+                    <a:p>
+                      <a:r>
+                        <a:rPr lang="en-US" dirty="0" err="1"/>
+                        <a:t>Job_title</a:t>
+                      </a:r>
                       <a:endParaRPr lang="en-US" dirty="0"/>
                     </a:p>
                   </a:txBody>
@@ -4644,64 +4401,43 @@
                     <a:bodyPr/>
                     <a:lstStyle/>
                     <a:p>
-                      <a:endParaRPr lang="en-US" dirty="0"/>
-                    </a:p>
-                  </a:txBody>
-                  <a:tcPr/>
-                </a:tc>
-                <a:tc>
-                  <a:txBody>
-                    <a:bodyPr/>
-                    <a:lstStyle/>
-                    <a:p>
-                      <a:endParaRPr lang="en-US" dirty="0"/>
-                    </a:p>
-                  </a:txBody>
-                  <a:tcPr/>
-                </a:tc>
-                <a:tc>
-                  <a:txBody>
-                    <a:bodyPr/>
-                    <a:lstStyle/>
-                    <a:p>
-                      <a:endParaRPr lang="en-US" dirty="0"/>
-                    </a:p>
-                  </a:txBody>
-                  <a:tcPr/>
-                </a:tc>
-                <a:tc>
-                  <a:txBody>
-                    <a:bodyPr/>
-                    <a:lstStyle/>
-                    <a:p>
-                      <a:endParaRPr lang="en-US" dirty="0"/>
-                    </a:p>
-                  </a:txBody>
-                  <a:tcPr/>
-                </a:tc>
-                <a:tc>
-                  <a:txBody>
-                    <a:bodyPr/>
-                    <a:lstStyle/>
-                    <a:p>
-                      <a:endParaRPr lang="en-US" dirty="0"/>
-                    </a:p>
-                  </a:txBody>
-                  <a:tcPr/>
-                </a:tc>
-                <a:tc>
-                  <a:txBody>
-                    <a:bodyPr/>
-                    <a:lstStyle/>
-                    <a:p>
-                      <a:endParaRPr lang="en-US"/>
+                      <a:r>
+                        <a:rPr lang="en-US" dirty="0"/>
+                        <a:t>Hours worked</a:t>
+                      </a:r>
+                    </a:p>
+                  </a:txBody>
+                  <a:tcPr/>
+                </a:tc>
+                <a:tc>
+                  <a:txBody>
+                    <a:bodyPr/>
+                    <a:lstStyle/>
+                    <a:p>
+                      <a:r>
+                        <a:rPr lang="en-US" dirty="0"/>
+                        <a:t>Classes</a:t>
+                      </a:r>
+                    </a:p>
+                  </a:txBody>
+                  <a:tcPr/>
+                </a:tc>
+                <a:tc>
+                  <a:txBody>
+                    <a:bodyPr/>
+                    <a:lstStyle/>
+                    <a:p>
+                      <a:r>
+                        <a:rPr lang="en-US" dirty="0"/>
+                        <a:t>Sales total</a:t>
+                      </a:r>
                     </a:p>
                   </a:txBody>
                   <a:tcPr/>
                 </a:tc>
                 <a:extLst>
                   <a:ext uri="{0D108BD9-81ED-4DB2-BD59-A6C34878D82A}">
-                    <a16:rowId xmlns:a16="http://schemas.microsoft.com/office/drawing/2014/main" val="961046695"/>
+                    <a16:rowId xmlns:a16="http://schemas.microsoft.com/office/drawing/2014/main" val="2171017020"/>
                   </a:ext>
                 </a:extLst>
               </a:tr>
@@ -4713,173 +4449,12 @@
                     <a:p>
                       <a:r>
                         <a:rPr lang="en-US" dirty="0"/>
-                        <a:t>DIM_DISTRICT</a:t>
-                      </a:r>
-                    </a:p>
-                  </a:txBody>
-                  <a:tcPr/>
-                </a:tc>
-                <a:tc>
-                  <a:txBody>
-                    <a:bodyPr/>
-                    <a:lstStyle/>
-                    <a:p>
-                      <a:endParaRPr lang="en-US" dirty="0"/>
-                    </a:p>
-                  </a:txBody>
-                  <a:tcPr/>
-                </a:tc>
-                <a:tc>
-                  <a:txBody>
-                    <a:bodyPr/>
-                    <a:lstStyle/>
-                    <a:p>
-                      <a:endParaRPr lang="en-US" dirty="0"/>
-                    </a:p>
-                  </a:txBody>
-                  <a:tcPr/>
-                </a:tc>
-                <a:tc>
-                  <a:txBody>
-                    <a:bodyPr/>
-                    <a:lstStyle/>
-                    <a:p>
-                      <a:endParaRPr lang="en-US" dirty="0">
-                        <a:highlight>
-                          <a:srgbClr val="FFFF00"/>
-                        </a:highlight>
-                      </a:endParaRPr>
-                    </a:p>
-                  </a:txBody>
-                  <a:tcPr/>
-                </a:tc>
-                <a:tc>
-                  <a:txBody>
-                    <a:bodyPr/>
-                    <a:lstStyle/>
-                    <a:p>
-                      <a:endParaRPr lang="en-US"/>
-                    </a:p>
-                  </a:txBody>
-                  <a:tcPr/>
-                </a:tc>
-                <a:tc>
-                  <a:txBody>
-                    <a:bodyPr/>
-                    <a:lstStyle/>
-                    <a:p>
-                      <a:endParaRPr lang="en-US"/>
-                    </a:p>
-                  </a:txBody>
-                  <a:tcPr/>
-                </a:tc>
-                <a:tc>
-                  <a:txBody>
-                    <a:bodyPr/>
-                    <a:lstStyle/>
-                    <a:p>
-                      <a:endParaRPr lang="en-US"/>
-                    </a:p>
-                  </a:txBody>
-                  <a:tcPr/>
-                </a:tc>
-                <a:extLst>
-                  <a:ext uri="{0D108BD9-81ED-4DB2-BD59-A6C34878D82A}">
-                    <a16:rowId xmlns:a16="http://schemas.microsoft.com/office/drawing/2014/main" val="2161244655"/>
-                  </a:ext>
-                </a:extLst>
-              </a:tr>
-              <a:tr h="370840">
-                <a:tc>
-                  <a:txBody>
-                    <a:bodyPr/>
-                    <a:lstStyle/>
-                    <a:p>
-                      <a:r>
-                        <a:rPr lang="en-US" dirty="0"/>
-                        <a:t>Club</a:t>
-                      </a:r>
-                    </a:p>
-                  </a:txBody>
-                  <a:tcPr/>
-                </a:tc>
-                <a:tc>
-                  <a:txBody>
-                    <a:bodyPr/>
-                    <a:lstStyle/>
-                    <a:p>
-                      <a:r>
-                        <a:rPr lang="en-US" dirty="0" err="1"/>
-                        <a:t>club_status</a:t>
-                      </a:r>
-                      <a:endParaRPr lang="en-US" dirty="0"/>
-                    </a:p>
-                  </a:txBody>
-                  <a:tcPr/>
-                </a:tc>
-                <a:tc>
-                  <a:txBody>
-                    <a:bodyPr/>
-                    <a:lstStyle/>
-                    <a:p>
-                      <a:r>
-                        <a:rPr lang="en-US" dirty="0"/>
-                        <a:t>region</a:t>
-                      </a:r>
-                    </a:p>
-                  </a:txBody>
-                  <a:tcPr/>
-                </a:tc>
-                <a:tc>
-                  <a:txBody>
-                    <a:bodyPr/>
-                    <a:lstStyle/>
-                    <a:p>
-                      <a:r>
-                        <a:rPr lang="en-US" dirty="0"/>
-                        <a:t>district</a:t>
-                      </a:r>
-                    </a:p>
-                  </a:txBody>
-                  <a:tcPr/>
-                </a:tc>
-                <a:tc>
-                  <a:txBody>
-                    <a:bodyPr/>
-                    <a:lstStyle/>
-                    <a:p>
-                      <a:endParaRPr lang="en-US" dirty="0"/>
-                    </a:p>
-                  </a:txBody>
-                  <a:tcPr/>
-                </a:tc>
-                <a:tc>
-                  <a:txBody>
-                    <a:bodyPr/>
-                    <a:lstStyle/>
-                    <a:p>
-                      <a:endParaRPr lang="en-US"/>
-                    </a:p>
-                  </a:txBody>
-                  <a:tcPr/>
-                </a:tc>
-                <a:tc>
-                  <a:txBody>
-                    <a:bodyPr/>
-                    <a:lstStyle/>
-                    <a:p>
-                      <a:endParaRPr lang="en-US"/>
-                    </a:p>
-                  </a:txBody>
-                  <a:tcPr/>
-                </a:tc>
-                <a:extLst>
-                  <a:ext uri="{0D108BD9-81ED-4DB2-BD59-A6C34878D82A}">
-                    <a16:rowId xmlns:a16="http://schemas.microsoft.com/office/drawing/2014/main" val="218932936"/>
-                  </a:ext>
-                </a:extLst>
-              </a:tr>
-              <a:tr h="370840">
+                        <a:t>00023</a:t>
+                      </a:r>
+                    </a:p>
+                  </a:txBody>
+                  <a:tcPr/>
+                </a:tc>
                 <a:tc>
                   <a:txBody>
                     <a:bodyPr/>
@@ -4888,32 +4463,6 @@
                       <a:r>
                         <a:rPr lang="en-US" dirty="0"/>
                         <a:t>01</a:t>
-                      </a:r>
-                    </a:p>
-                  </a:txBody>
-                  <a:tcPr/>
-                </a:tc>
-                <a:tc>
-                  <a:txBody>
-                    <a:bodyPr/>
-                    <a:lstStyle/>
-                    <a:p>
-                      <a:r>
-                        <a:rPr lang="en-US" dirty="0"/>
-                        <a:t>OPEN</a:t>
-                      </a:r>
-                    </a:p>
-                  </a:txBody>
-                  <a:tcPr/>
-                </a:tc>
-                <a:tc>
-                  <a:txBody>
-                    <a:bodyPr/>
-                    <a:lstStyle/>
-                    <a:p>
-                      <a:r>
-                        <a:rPr lang="en-US" dirty="0"/>
-                        <a:t>CALIFOR</a:t>
                       </a:r>
                     </a:p>
                   </a:txBody>
@@ -4941,34 +4490,56 @@
                     <a:bodyPr/>
                     <a:lstStyle/>
                     <a:p>
-                      <a:endParaRPr lang="en-US"/>
-                    </a:p>
-                  </a:txBody>
-                  <a:tcPr/>
-                </a:tc>
-                <a:tc>
-                  <a:txBody>
-                    <a:bodyPr/>
-                    <a:lstStyle/>
-                    <a:p>
-                      <a:endParaRPr lang="en-US"/>
-                    </a:p>
-                  </a:txBody>
-                  <a:tcPr/>
-                </a:tc>
-                <a:tc>
-                  <a:txBody>
-                    <a:bodyPr/>
-                    <a:lstStyle/>
-                    <a:p>
-                      <a:endParaRPr lang="en-US"/>
+                      <a:r>
+                        <a:rPr lang="en-US" dirty="0"/>
+                        <a:t>Manager</a:t>
+                      </a:r>
+                    </a:p>
+                  </a:txBody>
+                  <a:tcPr/>
+                </a:tc>
+                <a:tc>
+                  <a:txBody>
+                    <a:bodyPr/>
+                    <a:lstStyle/>
+                    <a:p>
+                      <a:r>
+                        <a:rPr lang="en-US" dirty="0"/>
+                        <a:t>80</a:t>
+                      </a:r>
+                    </a:p>
+                  </a:txBody>
+                  <a:tcPr/>
+                </a:tc>
+                <a:tc>
+                  <a:txBody>
+                    <a:bodyPr/>
+                    <a:lstStyle/>
+                    <a:p>
+                      <a:r>
+                        <a:rPr lang="en-US" dirty="0"/>
+                        <a:t>1</a:t>
+                      </a:r>
+                    </a:p>
+                  </a:txBody>
+                  <a:tcPr/>
+                </a:tc>
+                <a:tc>
+                  <a:txBody>
+                    <a:bodyPr/>
+                    <a:lstStyle/>
+                    <a:p>
+                      <a:r>
+                        <a:rPr lang="en-US" dirty="0"/>
+                        <a:t>80</a:t>
+                      </a:r>
                     </a:p>
                   </a:txBody>
                   <a:tcPr/>
                 </a:tc>
                 <a:extLst>
                   <a:ext uri="{0D108BD9-81ED-4DB2-BD59-A6C34878D82A}">
-                    <a16:rowId xmlns:a16="http://schemas.microsoft.com/office/drawing/2014/main" val="1451862729"/>
+                    <a16:rowId xmlns:a16="http://schemas.microsoft.com/office/drawing/2014/main" val="2624418906"/>
                   </a:ext>
                 </a:extLst>
               </a:tr>
@@ -4978,6 +4549,16 @@
                     <a:bodyPr/>
                     <a:lstStyle/>
                     <a:p>
+                      <a:endParaRPr lang="en-US" dirty="0"/>
+                    </a:p>
+                  </a:txBody>
+                  <a:tcPr/>
+                </a:tc>
+                <a:tc>
+                  <a:txBody>
+                    <a:bodyPr/>
+                    <a:lstStyle/>
+                    <a:p>
                       <a:r>
                         <a:rPr lang="en-US" dirty="0"/>
                         <a:t>02</a:t>
@@ -4993,32 +4574,6 @@
                     <a:p>
                       <a:r>
                         <a:rPr lang="en-US" dirty="0"/>
-                        <a:t>Close</a:t>
-                      </a:r>
-                    </a:p>
-                  </a:txBody>
-                  <a:tcPr/>
-                </a:tc>
-                <a:tc>
-                  <a:txBody>
-                    <a:bodyPr/>
-                    <a:lstStyle/>
-                    <a:p>
-                      <a:r>
-                        <a:rPr lang="en-US" dirty="0"/>
-                        <a:t>Oregon</a:t>
-                      </a:r>
-                    </a:p>
-                  </a:txBody>
-                  <a:tcPr/>
-                </a:tc>
-                <a:tc>
-                  <a:txBody>
-                    <a:bodyPr/>
-                    <a:lstStyle/>
-                    <a:p>
-                      <a:r>
-                        <a:rPr lang="en-US" dirty="0"/>
                         <a:t>WEST</a:t>
                       </a:r>
                     </a:p>
@@ -5030,34 +4585,56 @@
                     <a:bodyPr/>
                     <a:lstStyle/>
                     <a:p>
-                      <a:endParaRPr lang="en-US" dirty="0"/>
-                    </a:p>
-                  </a:txBody>
-                  <a:tcPr/>
-                </a:tc>
-                <a:tc>
-                  <a:txBody>
-                    <a:bodyPr/>
-                    <a:lstStyle/>
-                    <a:p>
-                      <a:endParaRPr lang="en-US"/>
-                    </a:p>
-                  </a:txBody>
-                  <a:tcPr/>
-                </a:tc>
-                <a:tc>
-                  <a:txBody>
-                    <a:bodyPr/>
-                    <a:lstStyle/>
-                    <a:p>
-                      <a:endParaRPr lang="en-US"/>
+                      <a:r>
+                        <a:rPr lang="en-US" dirty="0"/>
+                        <a:t>Employee</a:t>
+                      </a:r>
+                    </a:p>
+                  </a:txBody>
+                  <a:tcPr/>
+                </a:tc>
+                <a:tc>
+                  <a:txBody>
+                    <a:bodyPr/>
+                    <a:lstStyle/>
+                    <a:p>
+                      <a:r>
+                        <a:rPr lang="en-US" dirty="0"/>
+                        <a:t>20</a:t>
+                      </a:r>
+                    </a:p>
+                  </a:txBody>
+                  <a:tcPr/>
+                </a:tc>
+                <a:tc>
+                  <a:txBody>
+                    <a:bodyPr/>
+                    <a:lstStyle/>
+                    <a:p>
+                      <a:r>
+                        <a:rPr lang="en-US" dirty="0"/>
+                        <a:t>2</a:t>
+                      </a:r>
+                    </a:p>
+                  </a:txBody>
+                  <a:tcPr/>
+                </a:tc>
+                <a:tc>
+                  <a:txBody>
+                    <a:bodyPr/>
+                    <a:lstStyle/>
+                    <a:p>
+                      <a:r>
+                        <a:rPr lang="en-US" dirty="0"/>
+                        <a:t>90</a:t>
+                      </a:r>
                     </a:p>
                   </a:txBody>
                   <a:tcPr/>
                 </a:tc>
                 <a:extLst>
                   <a:ext uri="{0D108BD9-81ED-4DB2-BD59-A6C34878D82A}">
-                    <a16:rowId xmlns:a16="http://schemas.microsoft.com/office/drawing/2014/main" val="2950868142"/>
+                    <a16:rowId xmlns:a16="http://schemas.microsoft.com/office/drawing/2014/main" val="3708326895"/>
                   </a:ext>
                 </a:extLst>
               </a:tr>
@@ -5087,37 +4664,40 @@
                     <a:bodyPr/>
                     <a:lstStyle/>
                     <a:p>
-                      <a:endParaRPr lang="en-US"/>
-                    </a:p>
-                  </a:txBody>
-                  <a:tcPr/>
-                </a:tc>
-                <a:tc>
-                  <a:txBody>
-                    <a:bodyPr/>
-                    <a:lstStyle/>
-                    <a:p>
-                      <a:endParaRPr lang="en-US"/>
-                    </a:p>
-                  </a:txBody>
-                  <a:tcPr/>
-                </a:tc>
-                <a:tc>
-                  <a:txBody>
-                    <a:bodyPr/>
-                    <a:lstStyle/>
-                    <a:p>
-                      <a:endParaRPr lang="en-US"/>
-                    </a:p>
-                  </a:txBody>
-                  <a:tcPr/>
-                </a:tc>
-                <a:tc>
-                  <a:txBody>
-                    <a:bodyPr/>
-                    <a:lstStyle/>
-                    <a:p>
-                      <a:endParaRPr lang="en-US"/>
+                      <a:r>
+                        <a:rPr lang="en-US" dirty="0"/>
+                        <a:t>EAST</a:t>
+                      </a:r>
+                    </a:p>
+                  </a:txBody>
+                  <a:tcPr/>
+                </a:tc>
+                <a:tc>
+                  <a:txBody>
+                    <a:bodyPr/>
+                    <a:lstStyle/>
+                    <a:p>
+                      <a:endParaRPr lang="en-US"/>
+                    </a:p>
+                  </a:txBody>
+                  <a:tcPr/>
+                </a:tc>
+                <a:tc>
+                  <a:txBody>
+                    <a:bodyPr/>
+                    <a:lstStyle/>
+                    <a:p>
+                      <a:endParaRPr lang="en-US"/>
+                    </a:p>
+                  </a:txBody>
+                  <a:tcPr/>
+                </a:tc>
+                <a:tc>
+                  <a:txBody>
+                    <a:bodyPr/>
+                    <a:lstStyle/>
+                    <a:p>
+                      <a:endParaRPr lang="en-US" dirty="0"/>
                     </a:p>
                   </a:txBody>
                   <a:tcPr/>
@@ -5134,235 +4714,7 @@
                 </a:tc>
                 <a:extLst>
                   <a:ext uri="{0D108BD9-81ED-4DB2-BD59-A6C34878D82A}">
-                    <a16:rowId xmlns:a16="http://schemas.microsoft.com/office/drawing/2014/main" val="1901827370"/>
-                  </a:ext>
-                </a:extLst>
-              </a:tr>
-            </a:tbl>
-          </a:graphicData>
-        </a:graphic>
-      </p:graphicFrame>
-      <p:graphicFrame>
-        <p:nvGraphicFramePr>
-          <p:cNvPr id="7" name="Table 6">
-            <a:extLst>
-              <a:ext uri="{FF2B5EF4-FFF2-40B4-BE49-F238E27FC236}">
-                <a16:creationId xmlns:a16="http://schemas.microsoft.com/office/drawing/2014/main" id="{C364B901-84CB-615A-EA60-0843D3F2AE8A}"/>
-              </a:ext>
-            </a:extLst>
-          </p:cNvPr>
-          <p:cNvGraphicFramePr>
-            <a:graphicFrameLocks noGrp="1"/>
-          </p:cNvGraphicFramePr>
-          <p:nvPr>
-            <p:extLst>
-              <p:ext uri="{D42A27DB-BD31-4B8C-83A1-F6EECF244321}">
-                <p14:modId xmlns:p14="http://schemas.microsoft.com/office/powerpoint/2010/main" val="2582108659"/>
-              </p:ext>
-            </p:extLst>
-          </p:nvPr>
-        </p:nvGraphicFramePr>
-        <p:xfrm>
-          <a:off x="2032000" y="719666"/>
-          <a:ext cx="8128000" cy="370840"/>
-        </p:xfrm>
-        <a:graphic>
-          <a:graphicData uri="http://schemas.openxmlformats.org/drawingml/2006/table">
-            <a:tbl>
-              <a:tblPr firstRow="1" bandRow="1">
-                <a:tableStyleId>{5C22544A-7EE6-4342-B048-85BDC9FD1C3A}</a:tableStyleId>
-              </a:tblPr>
-              <a:tblGrid>
-                <a:gridCol w="8128000">
-                  <a:extLst>
-                    <a:ext uri="{9D8B030D-6E8A-4147-A177-3AD203B41FA5}">
-                      <a16:colId xmlns:a16="http://schemas.microsoft.com/office/drawing/2014/main" val="173596753"/>
-                    </a:ext>
-                  </a:extLst>
-                </a:gridCol>
-              </a:tblGrid>
-              <a:tr h="370840">
-                <a:tc>
-                  <a:txBody>
-                    <a:bodyPr/>
-                    <a:lstStyle/>
-                    <a:p>
-                      <a:endParaRPr lang="en-US" dirty="0"/>
-                    </a:p>
-                  </a:txBody>
-                  <a:tcPr/>
-                </a:tc>
-                <a:extLst>
-                  <a:ext uri="{0D108BD9-81ED-4DB2-BD59-A6C34878D82A}">
-                    <a16:rowId xmlns:a16="http://schemas.microsoft.com/office/drawing/2014/main" val="88767095"/>
-                  </a:ext>
-                </a:extLst>
-              </a:tr>
-            </a:tbl>
-          </a:graphicData>
-        </a:graphic>
-      </p:graphicFrame>
-      <p:graphicFrame>
-        <p:nvGraphicFramePr>
-          <p:cNvPr id="8" name="Table 7">
-            <a:extLst>
-              <a:ext uri="{FF2B5EF4-FFF2-40B4-BE49-F238E27FC236}">
-                <a16:creationId xmlns:a16="http://schemas.microsoft.com/office/drawing/2014/main" id="{607988A1-0E46-7451-9A1B-6C48BD00BC4D}"/>
-              </a:ext>
-            </a:extLst>
-          </p:cNvPr>
-          <p:cNvGraphicFramePr>
-            <a:graphicFrameLocks noGrp="1"/>
-          </p:cNvGraphicFramePr>
-          <p:nvPr>
-            <p:extLst>
-              <p:ext uri="{D42A27DB-BD31-4B8C-83A1-F6EECF244321}">
-                <p14:modId xmlns:p14="http://schemas.microsoft.com/office/powerpoint/2010/main" val="2941347729"/>
-              </p:ext>
-            </p:extLst>
-          </p:nvPr>
-        </p:nvGraphicFramePr>
-        <p:xfrm>
-          <a:off x="2031998" y="4583744"/>
-          <a:ext cx="8128001" cy="2296160"/>
-        </p:xfrm>
-        <a:graphic>
-          <a:graphicData uri="http://schemas.openxmlformats.org/drawingml/2006/table">
-            <a:tbl>
-              <a:tblPr firstRow="1" bandRow="1">
-                <a:tableStyleId>{5C22544A-7EE6-4342-B048-85BDC9FD1C3A}</a:tableStyleId>
-              </a:tblPr>
-              <a:tblGrid>
-                <a:gridCol w="1161143">
-                  <a:extLst>
-                    <a:ext uri="{9D8B030D-6E8A-4147-A177-3AD203B41FA5}">
-                      <a16:colId xmlns:a16="http://schemas.microsoft.com/office/drawing/2014/main" val="1431387303"/>
-                    </a:ext>
-                  </a:extLst>
-                </a:gridCol>
-                <a:gridCol w="1161143">
-                  <a:extLst>
-                    <a:ext uri="{9D8B030D-6E8A-4147-A177-3AD203B41FA5}">
-                      <a16:colId xmlns:a16="http://schemas.microsoft.com/office/drawing/2014/main" val="3560026816"/>
-                    </a:ext>
-                  </a:extLst>
-                </a:gridCol>
-                <a:gridCol w="1161143">
-                  <a:extLst>
-                    <a:ext uri="{9D8B030D-6E8A-4147-A177-3AD203B41FA5}">
-                      <a16:colId xmlns:a16="http://schemas.microsoft.com/office/drawing/2014/main" val="368700585"/>
-                    </a:ext>
-                  </a:extLst>
-                </a:gridCol>
-                <a:gridCol w="1161143">
-                  <a:extLst>
-                    <a:ext uri="{9D8B030D-6E8A-4147-A177-3AD203B41FA5}">
-                      <a16:colId xmlns:a16="http://schemas.microsoft.com/office/drawing/2014/main" val="46792183"/>
-                    </a:ext>
-                  </a:extLst>
-                </a:gridCol>
-                <a:gridCol w="1161143">
-                  <a:extLst>
-                    <a:ext uri="{9D8B030D-6E8A-4147-A177-3AD203B41FA5}">
-                      <a16:colId xmlns:a16="http://schemas.microsoft.com/office/drawing/2014/main" val="211209722"/>
-                    </a:ext>
-                  </a:extLst>
-                </a:gridCol>
-                <a:gridCol w="1161143">
-                  <a:extLst>
-                    <a:ext uri="{9D8B030D-6E8A-4147-A177-3AD203B41FA5}">
-                      <a16:colId xmlns:a16="http://schemas.microsoft.com/office/drawing/2014/main" val="1460515604"/>
-                    </a:ext>
-                  </a:extLst>
-                </a:gridCol>
-                <a:gridCol w="1161143">
-                  <a:extLst>
-                    <a:ext uri="{9D8B030D-6E8A-4147-A177-3AD203B41FA5}">
-                      <a16:colId xmlns:a16="http://schemas.microsoft.com/office/drawing/2014/main" val="809971710"/>
-                    </a:ext>
-                  </a:extLst>
-                </a:gridCol>
-              </a:tblGrid>
-              <a:tr h="370840">
-                <a:tc>
-                  <a:txBody>
-                    <a:bodyPr/>
-                    <a:lstStyle/>
-                    <a:p>
-                      <a:r>
-                        <a:rPr lang="en-US" dirty="0"/>
-                        <a:t>DIM_CLUB_STATUS</a:t>
-                      </a:r>
-                    </a:p>
-                  </a:txBody>
-                  <a:tcPr/>
-                </a:tc>
-                <a:tc>
-                  <a:txBody>
-                    <a:bodyPr/>
-                    <a:lstStyle/>
-                    <a:p>
-                      <a:endParaRPr lang="en-US"/>
-                    </a:p>
-                  </a:txBody>
-                  <a:tcPr/>
-                </a:tc>
-                <a:tc>
-                  <a:txBody>
-                    <a:bodyPr/>
-                    <a:lstStyle/>
-                    <a:p>
-                      <a:r>
-                        <a:rPr lang="en-US" dirty="0"/>
-                        <a:t>active</a:t>
-                      </a:r>
-                    </a:p>
-                  </a:txBody>
-                  <a:tcPr/>
-                </a:tc>
-                <a:tc>
-                  <a:txBody>
-                    <a:bodyPr/>
-                    <a:lstStyle/>
-                    <a:p>
-                      <a:endParaRPr lang="en-US"/>
-                    </a:p>
-                  </a:txBody>
-                  <a:tcPr/>
-                </a:tc>
-                <a:tc>
-                  <a:txBody>
-                    <a:bodyPr/>
-                    <a:lstStyle/>
-                    <a:p>
-                      <a:endParaRPr lang="en-US"/>
-                    </a:p>
-                  </a:txBody>
-                  <a:tcPr/>
-                </a:tc>
-                <a:tc>
-                  <a:txBody>
-                    <a:bodyPr/>
-                    <a:lstStyle/>
-                    <a:p>
-                      <a:endParaRPr lang="en-US"/>
-                    </a:p>
-                  </a:txBody>
-                  <a:tcPr/>
-                </a:tc>
-                <a:tc>
-                  <a:txBody>
-                    <a:bodyPr/>
-                    <a:lstStyle/>
-                    <a:p>
-                      <a:endParaRPr lang="en-US"/>
-                    </a:p>
-                  </a:txBody>
-                  <a:tcPr/>
-                </a:tc>
-                <a:extLst>
-                  <a:ext uri="{0D108BD9-81ED-4DB2-BD59-A6C34878D82A}">
-                    <a16:rowId xmlns:a16="http://schemas.microsoft.com/office/drawing/2014/main" val="3840449357"/>
+                    <a16:rowId xmlns:a16="http://schemas.microsoft.com/office/drawing/2014/main" val="2758168549"/>
                   </a:ext>
                 </a:extLst>
               </a:tr>
@@ -5372,85 +4724,77 @@
                     <a:bodyPr/>
                     <a:lstStyle/>
                     <a:p>
-                      <a:r>
-                        <a:rPr lang="en-US" dirty="0" err="1"/>
-                        <a:t>Status_name</a:t>
-                      </a:r>
-                      <a:endParaRPr lang="en-US" dirty="0"/>
-                    </a:p>
-                  </a:txBody>
-                  <a:tcPr/>
-                </a:tc>
-                <a:tc>
-                  <a:txBody>
-                    <a:bodyPr/>
-                    <a:lstStyle/>
-                    <a:p>
-                      <a:r>
-                        <a:rPr lang="en-US" dirty="0" err="1"/>
-                        <a:t>Status_id</a:t>
-                      </a:r>
-                      <a:endParaRPr lang="en-US" dirty="0"/>
-                    </a:p>
-                  </a:txBody>
-                  <a:tcPr/>
-                </a:tc>
-                <a:tc>
-                  <a:txBody>
-                    <a:bodyPr/>
-                    <a:lstStyle/>
-                    <a:p>
-                      <a:r>
-                        <a:rPr lang="en-US" dirty="0"/>
-                        <a:t>Active</a:t>
-                      </a:r>
-                    </a:p>
-                  </a:txBody>
-                  <a:tcPr/>
-                </a:tc>
-                <a:tc>
-                  <a:txBody>
-                    <a:bodyPr/>
-                    <a:lstStyle/>
-                    <a:p>
-                      <a:endParaRPr lang="en-US"/>
-                    </a:p>
-                  </a:txBody>
-                  <a:tcPr/>
-                </a:tc>
-                <a:tc>
-                  <a:txBody>
-                    <a:bodyPr/>
-                    <a:lstStyle/>
-                    <a:p>
-                      <a:endParaRPr lang="en-US"/>
-                    </a:p>
-                  </a:txBody>
-                  <a:tcPr/>
-                </a:tc>
-                <a:tc>
-                  <a:txBody>
-                    <a:bodyPr/>
-                    <a:lstStyle/>
-                    <a:p>
-                      <a:endParaRPr lang="en-US"/>
-                    </a:p>
-                  </a:txBody>
-                  <a:tcPr/>
-                </a:tc>
-                <a:tc>
-                  <a:txBody>
-                    <a:bodyPr/>
-                    <a:lstStyle/>
-                    <a:p>
-                      <a:endParaRPr lang="en-US" dirty="0"/>
+                      <a:endParaRPr lang="en-US"/>
+                    </a:p>
+                  </a:txBody>
+                  <a:tcPr/>
+                </a:tc>
+                <a:tc>
+                  <a:txBody>
+                    <a:bodyPr/>
+                    <a:lstStyle/>
+                    <a:p>
+                      <a:endParaRPr lang="en-US"/>
+                    </a:p>
+                  </a:txBody>
+                  <a:tcPr/>
+                </a:tc>
+                <a:tc>
+                  <a:txBody>
+                    <a:bodyPr/>
+                    <a:lstStyle/>
+                    <a:p>
+                      <a:r>
+                        <a:rPr lang="en-US" dirty="0"/>
+                        <a:t>MID</a:t>
+                      </a:r>
+                    </a:p>
+                  </a:txBody>
+                  <a:tcPr/>
+                </a:tc>
+                <a:tc>
+                  <a:txBody>
+                    <a:bodyPr/>
+                    <a:lstStyle/>
+                    <a:p>
+                      <a:endParaRPr lang="en-US"/>
+                    </a:p>
+                  </a:txBody>
+                  <a:tcPr/>
+                </a:tc>
+                <a:tc>
+                  <a:txBody>
+                    <a:bodyPr/>
+                    <a:lstStyle/>
+                    <a:p>
+                      <a:endParaRPr lang="en-US"/>
+                    </a:p>
+                  </a:txBody>
+                  <a:tcPr/>
+                </a:tc>
+                <a:tc>
+                  <a:txBody>
+                    <a:bodyPr/>
+                    <a:lstStyle/>
+                    <a:p>
+                      <a:endParaRPr lang="en-US"/>
+                    </a:p>
+                  </a:txBody>
+                  <a:tcPr/>
+                </a:tc>
+                <a:tc>
+                  <a:txBody>
+                    <a:bodyPr/>
+                    <a:lstStyle/>
+                    <a:p>
+                      <a:endParaRPr lang="en-US"/>
                     </a:p>
                   </a:txBody>
                   <a:tcPr/>
                 </a:tc>
                 <a:extLst>
                   <a:ext uri="{0D108BD9-81ED-4DB2-BD59-A6C34878D82A}">
-                    <a16:rowId xmlns:a16="http://schemas.microsoft.com/office/drawing/2014/main" val="361323667"/>
+                    <a16:rowId xmlns:a16="http://schemas.microsoft.com/office/drawing/2014/main" val="4087349432"/>
                   </a:ext>
                 </a:extLst>
               </a:tr>
@@ -5460,66 +4804,60 @@
                     <a:bodyPr/>
                     <a:lstStyle/>
                     <a:p>
-                      <a:r>
-                        <a:rPr lang="en-US" dirty="0"/>
-                        <a:t>Open</a:t>
-                      </a:r>
-                    </a:p>
-                  </a:txBody>
-                  <a:tcPr/>
-                </a:tc>
-                <a:tc>
-                  <a:txBody>
-                    <a:bodyPr/>
-                    <a:lstStyle/>
-                    <a:p>
-                      <a:r>
-                        <a:rPr lang="en-US" dirty="0"/>
-                        <a:t>01</a:t>
-                      </a:r>
-                    </a:p>
-                  </a:txBody>
-                  <a:tcPr/>
-                </a:tc>
-                <a:tc>
-                  <a:txBody>
-                    <a:bodyPr/>
-                    <a:lstStyle/>
-                    <a:p>
-                      <a:r>
-                        <a:rPr lang="en-US" dirty="0"/>
-                        <a:t>Inactive</a:t>
-                      </a:r>
-                    </a:p>
-                  </a:txBody>
-                  <a:tcPr/>
-                </a:tc>
-                <a:tc>
-                  <a:txBody>
-                    <a:bodyPr/>
-                    <a:lstStyle/>
-                    <a:p>
-                      <a:endParaRPr lang="en-US" dirty="0"/>
-                    </a:p>
-                  </a:txBody>
-                  <a:tcPr/>
-                </a:tc>
-                <a:tc>
-                  <a:txBody>
-                    <a:bodyPr/>
-                    <a:lstStyle/>
-                    <a:p>
-                      <a:endParaRPr lang="en-US" dirty="0"/>
-                    </a:p>
-                  </a:txBody>
-                  <a:tcPr/>
-                </a:tc>
-                <a:tc>
-                  <a:txBody>
-                    <a:bodyPr/>
-                    <a:lstStyle/>
-                    <a:p>
-                      <a:endParaRPr lang="en-US" dirty="0"/>
+                      <a:endParaRPr lang="en-US"/>
+                    </a:p>
+                  </a:txBody>
+                  <a:tcPr/>
+                </a:tc>
+                <a:tc>
+                  <a:txBody>
+                    <a:bodyPr/>
+                    <a:lstStyle/>
+                    <a:p>
+                      <a:endParaRPr lang="en-US"/>
+                    </a:p>
+                  </a:txBody>
+                  <a:tcPr/>
+                </a:tc>
+                <a:tc>
+                  <a:txBody>
+                    <a:bodyPr/>
+                    <a:lstStyle/>
+                    <a:p>
+                      <a:r>
+                        <a:rPr lang="en-US" dirty="0"/>
+                        <a:t>MID</a:t>
+                      </a:r>
+                    </a:p>
+                  </a:txBody>
+                  <a:tcPr/>
+                </a:tc>
+                <a:tc>
+                  <a:txBody>
+                    <a:bodyPr/>
+                    <a:lstStyle/>
+                    <a:p>
+                      <a:endParaRPr lang="en-US"/>
+                    </a:p>
+                  </a:txBody>
+                  <a:tcPr/>
+                </a:tc>
+                <a:tc>
+                  <a:txBody>
+                    <a:bodyPr/>
+                    <a:lstStyle/>
+                    <a:p>
+                      <a:endParaRPr lang="en-US"/>
+                    </a:p>
+                  </a:txBody>
+                  <a:tcPr/>
+                </a:tc>
+                <a:tc>
+                  <a:txBody>
+                    <a:bodyPr/>
+                    <a:lstStyle/>
+                    <a:p>
+                      <a:endParaRPr lang="en-US"/>
                     </a:p>
                   </a:txBody>
                   <a:tcPr/>
@@ -5536,198 +4874,7 @@
                 </a:tc>
                 <a:extLst>
                   <a:ext uri="{0D108BD9-81ED-4DB2-BD59-A6C34878D82A}">
-                    <a16:rowId xmlns:a16="http://schemas.microsoft.com/office/drawing/2014/main" val="3920785515"/>
-                  </a:ext>
-                </a:extLst>
-              </a:tr>
-              <a:tr h="370840">
-                <a:tc>
-                  <a:txBody>
-                    <a:bodyPr/>
-                    <a:lstStyle/>
-                    <a:p>
-                      <a:r>
-                        <a:rPr lang="en-US" dirty="0"/>
-                        <a:t>Closed</a:t>
-                      </a:r>
-                    </a:p>
-                  </a:txBody>
-                  <a:tcPr/>
-                </a:tc>
-                <a:tc>
-                  <a:txBody>
-                    <a:bodyPr/>
-                    <a:lstStyle/>
-                    <a:p>
-                      <a:r>
-                        <a:rPr lang="en-US" dirty="0"/>
-                        <a:t>02</a:t>
-                      </a:r>
-                    </a:p>
-                  </a:txBody>
-                  <a:tcPr/>
-                </a:tc>
-                <a:tc>
-                  <a:txBody>
-                    <a:bodyPr/>
-                    <a:lstStyle/>
-                    <a:p>
-                      <a:r>
-                        <a:rPr lang="en-US" dirty="0"/>
-                        <a:t>Active</a:t>
-                      </a:r>
-                    </a:p>
-                  </a:txBody>
-                  <a:tcPr/>
-                </a:tc>
-                <a:tc>
-                  <a:txBody>
-                    <a:bodyPr/>
-                    <a:lstStyle/>
-                    <a:p>
-                      <a:endParaRPr lang="en-US" dirty="0"/>
-                    </a:p>
-                  </a:txBody>
-                  <a:tcPr/>
-                </a:tc>
-                <a:tc>
-                  <a:txBody>
-                    <a:bodyPr/>
-                    <a:lstStyle/>
-                    <a:p>
-                      <a:endParaRPr lang="en-US" dirty="0"/>
-                    </a:p>
-                  </a:txBody>
-                  <a:tcPr/>
-                </a:tc>
-                <a:tc>
-                  <a:txBody>
-                    <a:bodyPr/>
-                    <a:lstStyle/>
-                    <a:p>
-                      <a:endParaRPr lang="en-US" dirty="0"/>
-                    </a:p>
-                  </a:txBody>
-                  <a:tcPr/>
-                </a:tc>
-                <a:tc>
-                  <a:txBody>
-                    <a:bodyPr/>
-                    <a:lstStyle/>
-                    <a:p>
-                      <a:endParaRPr lang="en-US" dirty="0"/>
-                    </a:p>
-                  </a:txBody>
-                  <a:tcPr/>
-                </a:tc>
-                <a:extLst>
-                  <a:ext uri="{0D108BD9-81ED-4DB2-BD59-A6C34878D82A}">
-                    <a16:rowId xmlns:a16="http://schemas.microsoft.com/office/drawing/2014/main" val="1664071834"/>
-                  </a:ext>
-                </a:extLst>
-              </a:tr>
-            </a:tbl>
-          </a:graphicData>
-        </a:graphic>
-      </p:graphicFrame>
-      <p:graphicFrame>
-        <p:nvGraphicFramePr>
-          <p:cNvPr id="9" name="Table 8">
-            <a:extLst>
-              <a:ext uri="{FF2B5EF4-FFF2-40B4-BE49-F238E27FC236}">
-                <a16:creationId xmlns:a16="http://schemas.microsoft.com/office/drawing/2014/main" id="{8A086500-41E6-5EA2-FF40-40681F2307E6}"/>
-              </a:ext>
-            </a:extLst>
-          </p:cNvPr>
-          <p:cNvGraphicFramePr>
-            <a:graphicFrameLocks noGrp="1"/>
-          </p:cNvGraphicFramePr>
-          <p:nvPr>
-            <p:extLst>
-              <p:ext uri="{D42A27DB-BD31-4B8C-83A1-F6EECF244321}">
-                <p14:modId xmlns:p14="http://schemas.microsoft.com/office/powerpoint/2010/main" val="1226881125"/>
-              </p:ext>
-            </p:extLst>
-          </p:nvPr>
-        </p:nvGraphicFramePr>
-        <p:xfrm>
-          <a:off x="10751573" y="452888"/>
-          <a:ext cx="3243827" cy="1567641"/>
-        </p:xfrm>
-        <a:graphic>
-          <a:graphicData uri="http://schemas.openxmlformats.org/drawingml/2006/table">
-            <a:tbl>
-              <a:tblPr firstRow="1" bandRow="1">
-                <a:tableStyleId>{5C22544A-7EE6-4342-B048-85BDC9FD1C3A}</a:tableStyleId>
-              </a:tblPr>
-              <a:tblGrid>
-                <a:gridCol w="3243827">
-                  <a:extLst>
-                    <a:ext uri="{9D8B030D-6E8A-4147-A177-3AD203B41FA5}">
-                      <a16:colId xmlns:a16="http://schemas.microsoft.com/office/drawing/2014/main" val="437840216"/>
-                    </a:ext>
-                  </a:extLst>
-                </a:gridCol>
-              </a:tblGrid>
-              <a:tr h="522547">
-                <a:tc>
-                  <a:txBody>
-                    <a:bodyPr/>
-                    <a:lstStyle/>
-                    <a:p>
-                      <a:r>
-                        <a:rPr lang="en-US" dirty="0"/>
-                        <a:t>Transformations</a:t>
-                      </a:r>
-                    </a:p>
-                  </a:txBody>
-                  <a:tcPr/>
-                </a:tc>
-                <a:extLst>
-                  <a:ext uri="{0D108BD9-81ED-4DB2-BD59-A6C34878D82A}">
-                    <a16:rowId xmlns:a16="http://schemas.microsoft.com/office/drawing/2014/main" val="2084044259"/>
-                  </a:ext>
-                </a:extLst>
-              </a:tr>
-              <a:tr h="522547">
-                <a:tc>
-                  <a:txBody>
-                    <a:bodyPr/>
-                    <a:lstStyle/>
-                    <a:p>
-                      <a:r>
-                        <a:rPr lang="en-US" dirty="0"/>
-                        <a:t>Remove </a:t>
-                      </a:r>
-                      <a:r>
-                        <a:rPr lang="en-US" dirty="0" err="1"/>
-                        <a:t>invactive</a:t>
-                      </a:r>
-                      <a:endParaRPr lang="en-US" dirty="0"/>
-                    </a:p>
-                  </a:txBody>
-                  <a:tcPr/>
-                </a:tc>
-                <a:extLst>
-                  <a:ext uri="{0D108BD9-81ED-4DB2-BD59-A6C34878D82A}">
-                    <a16:rowId xmlns:a16="http://schemas.microsoft.com/office/drawing/2014/main" val="4115967796"/>
-                  </a:ext>
-                </a:extLst>
-              </a:tr>
-              <a:tr h="522547">
-                <a:tc>
-                  <a:txBody>
-                    <a:bodyPr/>
-                    <a:lstStyle/>
-                    <a:p>
-                      <a:endParaRPr lang="en-US" dirty="0"/>
-                    </a:p>
-                  </a:txBody>
-                  <a:tcPr/>
-                </a:tc>
-                <a:extLst>
-                  <a:ext uri="{0D108BD9-81ED-4DB2-BD59-A6C34878D82A}">
-                    <a16:rowId xmlns:a16="http://schemas.microsoft.com/office/drawing/2014/main" val="3225210072"/>
+                    <a16:rowId xmlns:a16="http://schemas.microsoft.com/office/drawing/2014/main" val="1311239789"/>
                   </a:ext>
                 </a:extLst>
               </a:tr>

</xml_diff>